<commit_message>
added reference about clms vs mlms
</commit_message>
<xml_diff>
--- a/lectures/08_nlp_applications/08_nlp_applications.pptx
+++ b/lectures/08_nlp_applications/08_nlp_applications.pptx
@@ -148,7 +148,7 @@
 <file path=ppt/revisionInfo.xml><?xml version="1.0" encoding="utf-8"?>
 <p1510:revInfo xmlns:a="http://schemas.openxmlformats.org/drawingml/2006/main" xmlns:r="http://schemas.openxmlformats.org/officeDocument/2006/relationships" xmlns:p1510="http://schemas.microsoft.com/office/powerpoint/2015/10/main">
   <p1510:revLst>
-    <p1510:client id="{B7BD1DEC-658E-9A05-4664-D1209C8783AF}" v="2" dt="2025-05-30T12:11:02.267"/>
+    <p1510:client id="{A474F28D-C984-AB2B-61A7-1138376D0C4E}" v="57" dt="2025-07-22T14:39:07.682"/>
   </p1510:revLst>
 </p1510:revInfo>
 </file>
@@ -28601,7 +28601,7 @@
                 <a:ea typeface="+mj-lt"/>
                 <a:cs typeface="+mj-lt"/>
               </a:rPr>
-              <a:t>PLMs </a:t>
+              <a:t>CLMs </a:t>
             </a:r>
             <a:r>
               <a:rPr lang="de-DE" sz="3000" b="1" spc="-1" dirty="0" err="1">
@@ -28623,7 +28623,7 @@
                 <a:ea typeface="+mj-lt"/>
                 <a:cs typeface="+mj-lt"/>
               </a:rPr>
-              <a:t> LLMs</a:t>
+              <a:t> MLMs</a:t>
             </a:r>
             <a:endParaRPr lang="en-US" dirty="0"/>
           </a:p>
@@ -29119,8 +29119,18 @@
                   <a:srgbClr val="003056"/>
                 </a:solidFill>
                 <a:latin typeface="Calibri"/>
-              </a:rPr>
-              <a:t>Gap may have decreased since then, but question still fair</a:t>
+                <a:hlinkClick r:id="rId3"/>
+              </a:rPr>
+              <a:t>More recently</a:t>
+            </a:r>
+            <a:r>
+              <a:rPr lang="en-US" sz="2000" spc="-1">
+                <a:solidFill>
+                  <a:srgbClr val="003056"/>
+                </a:solidFill>
+                <a:latin typeface="Calibri"/>
+              </a:rPr>
+              <a:t>, MLMs better at classification, CLMs at generative tasks</a:t>
             </a:r>
           </a:p>
         </p:txBody>
@@ -29168,7 +29178,7 @@
           <p:nvPr/>
         </p:nvPicPr>
         <p:blipFill>
-          <a:blip r:embed="rId3"/>
+          <a:blip r:embed="rId4"/>
           <a:stretch>
             <a:fillRect/>
           </a:stretch>
@@ -29358,21 +29368,43 @@
                                   </p:childTnLst>
                                 </p:cTn>
                               </p:par>
+                            </p:childTnLst>
+                          </p:cTn>
+                        </p:par>
+                      </p:childTnLst>
+                    </p:cTn>
+                  </p:par>
+                  <p:par>
+                    <p:cTn id="15" fill="hold">
+                      <p:stCondLst>
+                        <p:cond delay="indefinite"/>
+                      </p:stCondLst>
+                      <p:childTnLst>
+                        <p:par>
+                          <p:cTn id="16" fill="hold">
+                            <p:stCondLst>
+                              <p:cond delay="0"/>
+                            </p:stCondLst>
+                            <p:childTnLst>
                               <p:par>
-                                <p:cTn id="15" presetID="1" presetClass="entr" presetSubtype="0" fill="hold" nodeType="withEffect">
+                                <p:cTn id="17" presetID="1" presetClass="entr" presetSubtype="0" fill="hold" grpId="0" nodeType="clickEffect">
                                   <p:stCondLst>
                                     <p:cond delay="0"/>
                                   </p:stCondLst>
                                   <p:childTnLst>
                                     <p:set>
                                       <p:cBhvr>
-                                        <p:cTn id="16" dur="1" fill="hold">
+                                        <p:cTn id="18" dur="1" fill="hold">
                                           <p:stCondLst>
                                             <p:cond delay="0"/>
                                           </p:stCondLst>
                                         </p:cTn>
                                         <p:tgtEl>
-                                          <p:spTgt spid="2"/>
+                                          <p:spTgt spid="90">
+                                            <p:txEl>
+                                              <p:pRg st="14" end="14"/>
+                                            </p:txEl>
+                                          </p:spTgt>
                                         </p:tgtEl>
                                         <p:attrNameLst>
                                           <p:attrName>style.visibility</p:attrName>
@@ -29385,26 +29417,8 @@
                                   </p:childTnLst>
                                 </p:cTn>
                               </p:par>
-                            </p:childTnLst>
-                          </p:cTn>
-                        </p:par>
-                      </p:childTnLst>
-                    </p:cTn>
-                  </p:par>
-                  <p:par>
-                    <p:cTn id="17" fill="hold">
-                      <p:stCondLst>
-                        <p:cond delay="indefinite"/>
-                      </p:stCondLst>
-                      <p:childTnLst>
-                        <p:par>
-                          <p:cTn id="18" fill="hold">
-                            <p:stCondLst>
-                              <p:cond delay="0"/>
-                            </p:stCondLst>
-                            <p:childTnLst>
                               <p:par>
-                                <p:cTn id="19" presetID="1" presetClass="entr" presetSubtype="0" fill="hold" grpId="0" nodeType="clickEffect">
+                                <p:cTn id="19" presetID="1" presetClass="entr" presetSubtype="0" fill="hold" nodeType="withEffect">
                                   <p:stCondLst>
                                     <p:cond delay="0"/>
                                   </p:stCondLst>
@@ -29417,11 +29431,7 @@
                                           </p:stCondLst>
                                         </p:cTn>
                                         <p:tgtEl>
-                                          <p:spTgt spid="90">
-                                            <p:txEl>
-                                              <p:pRg st="14" end="14"/>
-                                            </p:txEl>
-                                          </p:spTgt>
+                                          <p:spTgt spid="2"/>
                                         </p:tgtEl>
                                         <p:attrNameLst>
                                           <p:attrName>style.visibility</p:attrName>

</xml_diff>

<commit_message>
updated lectures 08 and 9 to 2026
</commit_message>
<xml_diff>
--- a/lectures/08_nlp_applications/08_nlp_applications.pptx
+++ b/lectures/08_nlp_applications/08_nlp_applications.pptx
@@ -148,7 +148,7 @@
 <file path=ppt/revisionInfo.xml><?xml version="1.0" encoding="utf-8"?>
 <p1510:revInfo xmlns:a="http://schemas.openxmlformats.org/drawingml/2006/main" xmlns:r="http://schemas.openxmlformats.org/officeDocument/2006/relationships" xmlns:p1510="http://schemas.microsoft.com/office/powerpoint/2015/10/main">
   <p1510:revLst>
-    <p1510:client id="{A474F28D-C984-AB2B-61A7-1138376D0C4E}" v="57" dt="2025-07-22T14:39:07.682"/>
+    <p1510:client id="{9649FD2B-456E-125F-06D6-A56A83C7BA69}" v="3" dt="2026-04-27T18:29:27.617"/>
   </p1510:revLst>
 </p1510:revInfo>
 </file>
@@ -187,7 +187,7 @@
           <a:p>
             <a:r>
               <a:rPr lang="en-US"/>
-              <a:t>Dr. Daniel Ruffinelli - FSS 2025</a:t>
+              <a:t>Dr. Daniel Ruffinelli - FSS 2026</a:t>
             </a:r>
             <a:endParaRPr/>
           </a:p>
@@ -391,7 +391,7 @@
           <a:p>
             <a:r>
               <a:rPr lang="en-US"/>
-              <a:t>Dr. Daniel Ruffinelli - FSS 2025</a:t>
+              <a:t>Dr. Daniel Ruffinelli - FSS 2026</a:t>
             </a:r>
             <a:endParaRPr/>
           </a:p>
@@ -671,7 +671,7 @@
           <a:p>
             <a:r>
               <a:rPr lang="en-US"/>
-              <a:t>Dr. Daniel Ruffinelli - FSS 2025</a:t>
+              <a:t>Dr. Daniel Ruffinelli - FSS 2026</a:t>
             </a:r>
             <a:endParaRPr/>
           </a:p>
@@ -1027,7 +1027,7 @@
           <a:p>
             <a:r>
               <a:rPr lang="en-US"/>
-              <a:t>Dr. Daniel Ruffinelli - FSS 2025</a:t>
+              <a:t>Dr. Daniel Ruffinelli - FSS 2026</a:t>
             </a:r>
             <a:endParaRPr/>
           </a:p>
@@ -1117,7 +1117,7 @@
           <a:p>
             <a:r>
               <a:rPr lang="en-US"/>
-              <a:t>Dr. Daniel Ruffinelli - FSS 2025</a:t>
+              <a:t>Dr. Daniel Ruffinelli - FSS 2026</a:t>
             </a:r>
             <a:endParaRPr/>
           </a:p>
@@ -1283,7 +1283,7 @@
           <a:p>
             <a:r>
               <a:rPr lang="en-US"/>
-              <a:t>Dr. Daniel Ruffinelli - FSS 2025</a:t>
+              <a:t>Dr. Daniel Ruffinelli - FSS 2026</a:t>
             </a:r>
             <a:endParaRPr/>
           </a:p>
@@ -1449,7 +1449,7 @@
           <a:p>
             <a:r>
               <a:rPr lang="en-US"/>
-              <a:t>Dr. Daniel Ruffinelli - FSS 2025</a:t>
+              <a:t>Dr. Daniel Ruffinelli - FSS 2026</a:t>
             </a:r>
             <a:endParaRPr/>
           </a:p>
@@ -1653,7 +1653,7 @@
           <a:p>
             <a:r>
               <a:rPr lang="en-US"/>
-              <a:t>Dr. Daniel Ruffinelli - FSS 2025</a:t>
+              <a:t>Dr. Daniel Ruffinelli - FSS 2026</a:t>
             </a:r>
             <a:endParaRPr/>
           </a:p>
@@ -1781,7 +1781,7 @@
           <a:p>
             <a:r>
               <a:rPr lang="en-US"/>
-              <a:t>Dr. Daniel Ruffinelli - FSS 2025</a:t>
+              <a:t>Dr. Daniel Ruffinelli - FSS 2026</a:t>
             </a:r>
             <a:endParaRPr/>
           </a:p>
@@ -1909,7 +1909,7 @@
           <a:p>
             <a:r>
               <a:rPr lang="en-US"/>
-              <a:t>Dr. Daniel Ruffinelli - FSS 2025</a:t>
+              <a:t>Dr. Daniel Ruffinelli - FSS 2026</a:t>
             </a:r>
             <a:endParaRPr/>
           </a:p>
@@ -2151,7 +2151,7 @@
           <a:p>
             <a:r>
               <a:rPr lang="en-US"/>
-              <a:t>Dr. Daniel Ruffinelli - FSS 2025</a:t>
+              <a:t>Dr. Daniel Ruffinelli - FSS 2026</a:t>
             </a:r>
             <a:endParaRPr/>
           </a:p>
@@ -2317,7 +2317,7 @@
           <a:p>
             <a:r>
               <a:rPr lang="en-US"/>
-              <a:t>Dr. Daniel Ruffinelli - FSS 2025</a:t>
+              <a:t>Dr. Daniel Ruffinelli - FSS 2026</a:t>
             </a:r>
             <a:endParaRPr/>
           </a:p>
@@ -2559,7 +2559,7 @@
           <a:p>
             <a:r>
               <a:rPr lang="en-US"/>
-              <a:t>Dr. Daniel Ruffinelli - FSS 2025</a:t>
+              <a:t>Dr. Daniel Ruffinelli - FSS 2026</a:t>
             </a:r>
             <a:endParaRPr/>
           </a:p>
@@ -2801,7 +2801,7 @@
           <a:p>
             <a:r>
               <a:rPr lang="en-US"/>
-              <a:t>Dr. Daniel Ruffinelli - FSS 2025</a:t>
+              <a:t>Dr. Daniel Ruffinelli - FSS 2026</a:t>
             </a:r>
             <a:endParaRPr/>
           </a:p>
@@ -3005,7 +3005,7 @@
           <a:p>
             <a:r>
               <a:rPr lang="en-US"/>
-              <a:t>Dr. Daniel Ruffinelli - FSS 2025</a:t>
+              <a:t>Dr. Daniel Ruffinelli - FSS 2026</a:t>
             </a:r>
             <a:endParaRPr/>
           </a:p>
@@ -3285,7 +3285,7 @@
           <a:p>
             <a:r>
               <a:rPr lang="en-US"/>
-              <a:t>Dr. Daniel Ruffinelli - FSS 2025</a:t>
+              <a:t>Dr. Daniel Ruffinelli - FSS 2026</a:t>
             </a:r>
             <a:endParaRPr/>
           </a:p>
@@ -3641,7 +3641,7 @@
           <a:p>
             <a:r>
               <a:rPr lang="en-US"/>
-              <a:t>Dr. Daniel Ruffinelli - FSS 2025</a:t>
+              <a:t>Dr. Daniel Ruffinelli - FSS 2026</a:t>
             </a:r>
             <a:endParaRPr/>
           </a:p>
@@ -3807,7 +3807,7 @@
           <a:p>
             <a:r>
               <a:rPr lang="en-US"/>
-              <a:t>Dr. Daniel Ruffinelli - FSS 2025</a:t>
+              <a:t>Dr. Daniel Ruffinelli - FSS 2026</a:t>
             </a:r>
             <a:endParaRPr/>
           </a:p>
@@ -4011,7 +4011,7 @@
           <a:p>
             <a:r>
               <a:rPr lang="en-US"/>
-              <a:t>Dr. Daniel Ruffinelli - FSS 2025</a:t>
+              <a:t>Dr. Daniel Ruffinelli - FSS 2026</a:t>
             </a:r>
             <a:endParaRPr/>
           </a:p>
@@ -4139,7 +4139,7 @@
           <a:p>
             <a:r>
               <a:rPr lang="en-US"/>
-              <a:t>Dr. Daniel Ruffinelli - FSS 2025</a:t>
+              <a:t>Dr. Daniel Ruffinelli - FSS 2026</a:t>
             </a:r>
             <a:endParaRPr/>
           </a:p>
@@ -4267,7 +4267,7 @@
           <a:p>
             <a:r>
               <a:rPr lang="en-US"/>
-              <a:t>Dr. Daniel Ruffinelli - FSS 2025</a:t>
+              <a:t>Dr. Daniel Ruffinelli - FSS 2026</a:t>
             </a:r>
             <a:endParaRPr/>
           </a:p>
@@ -4509,7 +4509,7 @@
           <a:p>
             <a:r>
               <a:rPr lang="en-US"/>
-              <a:t>Dr. Daniel Ruffinelli - FSS 2025</a:t>
+              <a:t>Dr. Daniel Ruffinelli - FSS 2026</a:t>
             </a:r>
             <a:endParaRPr/>
           </a:p>
@@ -4751,7 +4751,7 @@
           <a:p>
             <a:r>
               <a:rPr lang="en-US"/>
-              <a:t>Dr. Daniel Ruffinelli - FSS 2025</a:t>
+              <a:t>Dr. Daniel Ruffinelli - FSS 2026</a:t>
             </a:r>
             <a:endParaRPr/>
           </a:p>
@@ -4993,7 +4993,7 @@
           <a:p>
             <a:r>
               <a:rPr lang="en-US"/>
-              <a:t>Dr. Daniel Ruffinelli - FSS 2025</a:t>
+              <a:t>Dr. Daniel Ruffinelli - FSS 2026</a:t>
             </a:r>
             <a:endParaRPr/>
           </a:p>
@@ -5268,7 +5268,7 @@
                 </a:solidFill>
                 <a:latin typeface="Calibri"/>
               </a:rPr>
-              <a:t>Dr. Daniel Ruffinelli - FSS 2025</a:t>
+              <a:t>Dr. Daniel Ruffinelli - FSS 2026</a:t>
             </a:r>
             <a:endParaRPr lang="en-US" sz="1200" b="0" strike="noStrike" spc="-1">
               <a:latin typeface="Times New Roman"/>
@@ -6217,7 +6217,7 @@
                 </a:solidFill>
                 <a:latin typeface="Calibri"/>
               </a:rPr>
-              <a:t>Dr. Daniel Ruffinelli - FSS 2025</a:t>
+              <a:t>Dr. Daniel Ruffinelli - FSS 2026</a:t>
             </a:r>
             <a:endParaRPr lang="en-US" sz="1200" b="0" strike="noStrike" spc="-1">
               <a:latin typeface="Times New Roman"/>
@@ -6770,7 +6770,7 @@
                 </a:solidFill>
                 <a:latin typeface="Calibri"/>
               </a:rPr>
-              <a:t>Dr. Daniel Ruffinelli - FSS 2025</a:t>
+              <a:t>Dr. Daniel Ruffinelli - FSS 2026</a:t>
             </a:r>
             <a:endParaRPr lang="en-US" sz="1200" b="0" strike="noStrike" spc="-1">
               <a:latin typeface="Times New Roman"/>
@@ -7119,7 +7119,7 @@
                 </a:solidFill>
                 <a:latin typeface="Calibri"/>
               </a:rPr>
-              <a:t>Dr. Daniel Ruffinelli - FSS 2025</a:t>
+              <a:t>Dr. Daniel Ruffinelli - FSS 2026</a:t>
             </a:r>
             <a:endParaRPr lang="en-US" sz="1200" b="0" strike="noStrike" spc="-1">
               <a:latin typeface="Times New Roman"/>
@@ -8445,7 +8445,7 @@
                 </a:solidFill>
                 <a:latin typeface="Calibri"/>
               </a:rPr>
-              <a:t>Dr. Daniel Ruffinelli - FSS 2025</a:t>
+              <a:t>Dr. Daniel Ruffinelli - FSS 2026</a:t>
             </a:r>
             <a:endParaRPr lang="en-US" sz="1200" b="0" strike="noStrike" spc="-1">
               <a:latin typeface="Times New Roman"/>
@@ -10110,7 +10110,7 @@
                 </a:solidFill>
                 <a:latin typeface="Calibri"/>
               </a:rPr>
-              <a:t>Dr. Daniel Ruffinelli - FSS 2025</a:t>
+              <a:t>Dr. Daniel Ruffinelli - FSS 2026</a:t>
             </a:r>
             <a:endParaRPr lang="en-US" sz="1200" b="0" strike="noStrike" spc="-1">
               <a:latin typeface="Times New Roman"/>
@@ -11513,7 +11513,7 @@
                 </a:solidFill>
                 <a:latin typeface="Calibri"/>
               </a:rPr>
-              <a:t>Dr. Daniel Ruffinelli - FSS 2025</a:t>
+              <a:t>Dr. Daniel Ruffinelli - FSS 2026</a:t>
             </a:r>
             <a:endParaRPr lang="en-US" sz="1200" b="0" strike="noStrike" spc="-1">
               <a:latin typeface="Times New Roman"/>
@@ -12490,7 +12490,7 @@
                 </a:solidFill>
                 <a:latin typeface="Calibri"/>
               </a:rPr>
-              <a:t>Dr. Daniel Ruffinelli - FSS 2025</a:t>
+              <a:t>Dr. Daniel Ruffinelli - FSS 2026</a:t>
             </a:r>
             <a:endParaRPr lang="en-US" sz="1200" b="0" strike="noStrike" spc="-1">
               <a:latin typeface="Times New Roman"/>
@@ -14794,7 +14794,7 @@
                 </a:solidFill>
                 <a:latin typeface="Calibri"/>
               </a:rPr>
-              <a:t>Dr. Daniel Ruffinelli - FSS 2025</a:t>
+              <a:t>Dr. Daniel Ruffinelli - FSS 2026</a:t>
             </a:r>
             <a:endParaRPr lang="en-US" sz="1200" b="0" strike="noStrike" spc="-1">
               <a:latin typeface="Times New Roman"/>
@@ -16116,7 +16116,7 @@
                 </a:solidFill>
                 <a:latin typeface="Calibri"/>
               </a:rPr>
-              <a:t>Dr. Daniel Ruffinelli - FSS 2025</a:t>
+              <a:t>Dr. Daniel Ruffinelli - FSS 2026</a:t>
             </a:r>
             <a:endParaRPr lang="en-US" sz="1200" b="0" strike="noStrike" spc="-1">
               <a:latin typeface="Times New Roman"/>
@@ -17503,7 +17503,7 @@
                 </a:solidFill>
                 <a:latin typeface="Calibri"/>
               </a:rPr>
-              <a:t>Dr. Daniel Ruffinelli - FSS 2025</a:t>
+              <a:t>Dr. Daniel Ruffinelli - FSS 2026</a:t>
             </a:r>
             <a:endParaRPr lang="en-US" sz="1200" b="0" strike="noStrike" spc="-1">
               <a:latin typeface="Times New Roman"/>
@@ -18871,7 +18871,7 @@
                 </a:solidFill>
                 <a:latin typeface="Calibri"/>
               </a:rPr>
-              <a:t>Dr. Daniel Ruffinelli - FSS 2025</a:t>
+              <a:t>Dr. Daniel Ruffinelli - FSS 2026</a:t>
             </a:r>
             <a:endParaRPr lang="en-US" sz="1200" b="0" strike="noStrike" spc="-1">
               <a:latin typeface="Times New Roman"/>
@@ -19964,7 +19964,7 @@
                 </a:solidFill>
                 <a:latin typeface="Calibri"/>
               </a:rPr>
-              <a:t>Dr. Daniel Ruffinelli - FSS 2025</a:t>
+              <a:t>Dr. Daniel Ruffinelli - FSS 2026</a:t>
             </a:r>
             <a:endParaRPr lang="en-US" sz="1200" b="0" strike="noStrike" spc="-1">
               <a:latin typeface="Times New Roman"/>
@@ -21038,7 +21038,7 @@
                 </a:solidFill>
                 <a:latin typeface="Calibri"/>
               </a:rPr>
-              <a:t>Dr. Daniel Ruffinelli - FSS 2025</a:t>
+              <a:t>Dr. Daniel Ruffinelli - FSS 2026</a:t>
             </a:r>
             <a:endParaRPr lang="en-US" sz="1200" b="0" strike="noStrike" spc="-1">
               <a:latin typeface="Times New Roman"/>
@@ -22344,7 +22344,7 @@
                 </a:solidFill>
                 <a:latin typeface="Calibri"/>
               </a:rPr>
-              <a:t>Dr. Daniel Ruffinelli - FSS 2025</a:t>
+              <a:t>Dr. Daniel Ruffinelli - FSS 2026</a:t>
             </a:r>
             <a:endParaRPr lang="en-US" sz="1200" b="0" strike="noStrike" spc="-1">
               <a:latin typeface="Times New Roman"/>
@@ -23641,7 +23641,7 @@
                 </a:solidFill>
                 <a:latin typeface="Calibri"/>
               </a:rPr>
-              <a:t>Dr. Daniel Ruffinelli - FSS 2025</a:t>
+              <a:t>Dr. Daniel Ruffinelli - FSS 2026</a:t>
             </a:r>
             <a:endParaRPr lang="en-US" sz="1200" b="0" strike="noStrike" spc="-1">
               <a:latin typeface="Times New Roman"/>
@@ -24608,7 +24608,7 @@
                 </a:solidFill>
                 <a:latin typeface="Calibri"/>
               </a:rPr>
-              <a:t>Dr. Daniel Ruffinelli - FSS 2025</a:t>
+              <a:t>Dr. Daniel Ruffinelli - FSS 2026</a:t>
             </a:r>
             <a:endParaRPr lang="en-US" sz="1200" b="0" strike="noStrike" spc="-1">
               <a:latin typeface="Times New Roman"/>
@@ -25564,7 +25564,7 @@
                 </a:solidFill>
                 <a:latin typeface="Calibri"/>
               </a:rPr>
-              <a:t>Dr. Daniel Ruffinelli - FSS 2025</a:t>
+              <a:t>Dr. Daniel Ruffinelli - FSS 2026</a:t>
             </a:r>
             <a:endParaRPr lang="en-US" sz="1200" b="0" strike="noStrike" spc="-1">
               <a:latin typeface="Times New Roman"/>
@@ -26426,7 +26426,7 @@
                 </a:solidFill>
                 <a:latin typeface="Calibri"/>
               </a:rPr>
-              <a:t>Dr. Daniel Ruffinelli - FSS 2025</a:t>
+              <a:t>Dr. Daniel Ruffinelli - FSS 2026</a:t>
             </a:r>
             <a:endParaRPr lang="en-US" sz="1200" b="0" strike="noStrike" spc="-1">
               <a:latin typeface="Times New Roman"/>
@@ -27531,7 +27531,7 @@
                 </a:solidFill>
                 <a:latin typeface="Calibri"/>
               </a:rPr>
-              <a:t>Dr. Daniel Ruffinelli - FSS 2025</a:t>
+              <a:t>Dr. Daniel Ruffinelli - FSS 2026</a:t>
             </a:r>
             <a:endParaRPr lang="en-US" sz="1200" b="0" strike="noStrike" spc="-1">
               <a:latin typeface="Times New Roman"/>
@@ -28690,7 +28690,7 @@
                 </a:solidFill>
                 <a:latin typeface="Calibri"/>
               </a:rPr>
-              <a:t>Dr. Daniel Ruffinelli - FSS 2025</a:t>
+              <a:t>Dr. Daniel Ruffinelli - FSS 2026</a:t>
             </a:r>
             <a:endParaRPr lang="en-US" sz="1200" b="0" strike="noStrike" spc="-1">
               <a:latin typeface="Times New Roman"/>
@@ -29617,7 +29617,7 @@
                 </a:solidFill>
                 <a:latin typeface="Calibri"/>
               </a:rPr>
-              <a:t>Dr. Daniel Ruffinelli - FSS 2025</a:t>
+              <a:t>Dr. Daniel Ruffinelli - FSS 2026</a:t>
             </a:r>
             <a:endParaRPr lang="en-US" sz="1200" b="0" strike="noStrike" spc="-1">
               <a:latin typeface="Times New Roman"/>
@@ -30810,7 +30810,7 @@
                 </a:solidFill>
                 <a:latin typeface="Calibri"/>
               </a:rPr>
-              <a:t>Dr. Daniel Ruffinelli - FSS 2025</a:t>
+              <a:t>Dr. Daniel Ruffinelli - FSS 2026</a:t>
             </a:r>
             <a:endParaRPr lang="en-US" sz="1200" b="0" strike="noStrike" spc="-1">
               <a:latin typeface="Times New Roman"/>
@@ -31140,7 +31140,7 @@
                 </a:solidFill>
                 <a:latin typeface="Calibri"/>
               </a:rPr>
-              <a:t>Dr. Daniel Ruffinelli - FSS 2025</a:t>
+              <a:t>Dr. Daniel Ruffinelli - FSS 2026</a:t>
             </a:r>
             <a:endParaRPr lang="en-US" sz="1200" b="0" strike="noStrike" spc="-1">
               <a:latin typeface="Times New Roman"/>
@@ -32568,7 +32568,7 @@
                 </a:solidFill>
                 <a:latin typeface="Calibri"/>
               </a:rPr>
-              <a:t>Dr. Daniel Ruffinelli - FSS 2025</a:t>
+              <a:t>Dr. Daniel Ruffinelli - FSS 2026</a:t>
             </a:r>
             <a:endParaRPr lang="en-US" sz="1200" b="0" strike="noStrike" spc="-1">
               <a:latin typeface="Times New Roman"/>
@@ -33058,7 +33058,7 @@
                 </a:solidFill>
                 <a:latin typeface="Calibri"/>
               </a:rPr>
-              <a:t>Dr. Daniel Ruffinelli - FSS 2025</a:t>
+              <a:t>Dr. Daniel Ruffinelli - FSS 2026</a:t>
             </a:r>
             <a:endParaRPr lang="en-US" sz="1200" b="0" strike="noStrike" spc="-1">
               <a:latin typeface="Times New Roman"/>
@@ -34673,7 +34673,7 @@
                 </a:solidFill>
                 <a:latin typeface="Calibri"/>
               </a:rPr>
-              <a:t>Dr. Daniel Ruffinelli - FSS 2025</a:t>
+              <a:t>Dr. Daniel Ruffinelli - FSS 2026</a:t>
             </a:r>
             <a:endParaRPr lang="en-US" sz="1200" b="0" strike="noStrike" spc="-1">
               <a:latin typeface="Times New Roman"/>
@@ -35156,7 +35156,7 @@
                 </a:solidFill>
                 <a:latin typeface="Calibri"/>
               </a:rPr>
-              <a:t>Dr. Daniel Ruffinelli - FSS 2025</a:t>
+              <a:t>Dr. Daniel Ruffinelli - FSS 2026</a:t>
             </a:r>
             <a:endParaRPr lang="en-US" sz="1200" b="0" strike="noStrike" spc="-1">
               <a:latin typeface="Times New Roman"/>
@@ -36129,7 +36129,7 @@
                 </a:solidFill>
                 <a:latin typeface="Calibri"/>
               </a:rPr>
-              <a:t>Dr. Daniel Ruffinelli - FSS 2025</a:t>
+              <a:t>Dr. Daniel Ruffinelli - FSS 2026</a:t>
             </a:r>
             <a:endParaRPr lang="en-US" sz="1200" b="0" strike="noStrike" spc="-1">
               <a:latin typeface="Times New Roman"/>
@@ -37430,7 +37430,7 @@
                 </a:solidFill>
                 <a:latin typeface="Calibri"/>
               </a:rPr>
-              <a:t>Dr. Daniel Ruffinelli - FSS 2025</a:t>
+              <a:t>Dr. Daniel Ruffinelli - FSS 2026</a:t>
             </a:r>
             <a:endParaRPr lang="en-US" sz="1200" b="0" strike="noStrike" spc="-1">
               <a:latin typeface="Times New Roman"/>
@@ -38632,7 +38632,7 @@
                 </a:solidFill>
                 <a:latin typeface="Calibri"/>
               </a:rPr>
-              <a:t>Dr. Daniel Ruffinelli - FSS 2025</a:t>
+              <a:t>Dr. Daniel Ruffinelli - FSS 2026</a:t>
             </a:r>
             <a:endParaRPr lang="en-US" sz="1200" b="0" strike="noStrike" spc="-1">
               <a:latin typeface="Times New Roman"/>
@@ -39941,7 +39941,7 @@
                 </a:solidFill>
                 <a:latin typeface="Calibri"/>
               </a:rPr>
-              <a:t>Dr. Daniel Ruffinelli - FSS 2025</a:t>
+              <a:t>Dr. Daniel Ruffinelli - FSS 2026</a:t>
             </a:r>
             <a:endParaRPr lang="en-US" sz="1200" b="0" strike="noStrike" spc="-1">
               <a:latin typeface="Times New Roman"/>
@@ -41009,7 +41009,7 @@
                 </a:solidFill>
                 <a:latin typeface="Calibri"/>
               </a:rPr>
-              <a:t>Dr. Daniel Ruffinelli - FSS 2025</a:t>
+              <a:t>Dr. Daniel Ruffinelli - FSS 2026</a:t>
             </a:r>
             <a:endParaRPr lang="en-US" sz="1200" b="0" strike="noStrike" spc="-1">
               <a:latin typeface="Times New Roman"/>
@@ -42062,7 +42062,7 @@
                 </a:solidFill>
                 <a:latin typeface="Calibri"/>
               </a:rPr>
-              <a:t>Dr. Daniel Ruffinelli - FSS 2025</a:t>
+              <a:t>Dr. Daniel Ruffinelli - FSS 2026</a:t>
             </a:r>
             <a:endParaRPr lang="en-US" sz="1200" b="0" strike="noStrike" spc="-1">
               <a:latin typeface="Times New Roman"/>
@@ -42811,7 +42811,7 @@
                 </a:solidFill>
                 <a:latin typeface="Calibri"/>
               </a:rPr>
-              <a:t>Dr. Daniel Ruffinelli - FSS 2025</a:t>
+              <a:t>Dr. Daniel Ruffinelli - FSS 2026</a:t>
             </a:r>
             <a:endParaRPr lang="en-US" sz="1200" b="0" strike="noStrike" spc="-1">
               <a:latin typeface="Times New Roman"/>
@@ -43180,7 +43180,7 @@
                 </a:solidFill>
                 <a:latin typeface="Calibri"/>
               </a:rPr>
-              <a:t>Dr. Daniel Ruffinelli - FSS 2025</a:t>
+              <a:t>Dr. Daniel Ruffinelli - FSS 2026</a:t>
             </a:r>
             <a:endParaRPr lang="en-US" sz="1200" b="0" strike="noStrike" spc="-1">
               <a:latin typeface="Times New Roman"/>
@@ -44375,7 +44375,7 @@
                 </a:solidFill>
                 <a:latin typeface="Calibri"/>
               </a:rPr>
-              <a:t>Dr. Daniel Ruffinelli - FSS 2025</a:t>
+              <a:t>Dr. Daniel Ruffinelli - FSS 2026</a:t>
             </a:r>
             <a:endParaRPr lang="en-US" sz="1200" b="0" strike="noStrike" spc="-1">
               <a:latin typeface="Times New Roman"/>
@@ -45416,7 +45416,7 @@
                 </a:solidFill>
                 <a:latin typeface="Calibri"/>
               </a:rPr>
-              <a:t>Dr. Daniel Ruffinelli - FSS 2025</a:t>
+              <a:t>Dr. Daniel Ruffinelli - FSS 2026</a:t>
             </a:r>
             <a:endParaRPr lang="en-US" sz="1200" b="0" strike="noStrike" spc="-1">
               <a:latin typeface="Times New Roman"/>
@@ -46913,7 +46913,7 @@
                 </a:solidFill>
                 <a:latin typeface="Calibri"/>
               </a:rPr>
-              <a:t>Dr. Daniel Ruffinelli - FSS 2025</a:t>
+              <a:t>Dr. Daniel Ruffinelli - FSS 2026</a:t>
             </a:r>
             <a:endParaRPr lang="en-US" sz="1200" b="0" strike="noStrike" spc="-1">
               <a:latin typeface="Times New Roman"/>
@@ -48523,7 +48523,7 @@
                 </a:solidFill>
                 <a:latin typeface="Calibri"/>
               </a:rPr>
-              <a:t>Dr. Daniel Ruffinelli - FSS 2025</a:t>
+              <a:t>Dr. Daniel Ruffinelli - FSS 2026</a:t>
             </a:r>
             <a:endParaRPr lang="en-US" sz="1200" b="0" strike="noStrike" spc="-1">
               <a:latin typeface="Times New Roman"/>

</xml_diff>